<commit_message>
Add authorized own-voice narration and update submission wording
</commit_message>
<xml_diff>
--- a/submission/ming-slides.pptx
+++ b/submission/ming-slides.pptx
@@ -2,20 +2,20 @@
 <file path=ppt/presentation.xml><?xml version="1.0" encoding="utf-8"?>
 <p:presentation xmlns:p="http://schemas.openxmlformats.org/presentationml/2006/main">
   <p:sldMasterIdLst>
-    <p:sldMasterId xmlns:r="http://schemas.openxmlformats.org/officeDocument/2006/relationships" id="2147483648" r:id="Rff6fd7902f3741f8"/>
+    <p:sldMasterId xmlns:r="http://schemas.openxmlformats.org/officeDocument/2006/relationships" id="2147483648" r:id="R9c92e3b7f7054620"/>
   </p:sldMasterIdLst>
   <p:notesMasterIdLst>
-    <p:notesMasterId xmlns:r="http://schemas.openxmlformats.org/officeDocument/2006/relationships" r:id="Rea6862a3487242fc"/>
+    <p:notesMasterId xmlns:r="http://schemas.openxmlformats.org/officeDocument/2006/relationships" r:id="R0cdb0ced227b442c"/>
   </p:notesMasterIdLst>
   <p:sldIdLst>
-    <p:sldId xmlns:r="http://schemas.openxmlformats.org/officeDocument/2006/relationships" id="256" r:id="Rb248fc9317a74c03"/>
-    <p:sldId xmlns:r="http://schemas.openxmlformats.org/officeDocument/2006/relationships" id="257" r:id="Rfd6f9c15df3d4a22"/>
-    <p:sldId xmlns:r="http://schemas.openxmlformats.org/officeDocument/2006/relationships" id="258" r:id="R7d384e0c50474dac"/>
-    <p:sldId xmlns:r="http://schemas.openxmlformats.org/officeDocument/2006/relationships" id="259" r:id="R053f66af2a9e49f3"/>
-    <p:sldId xmlns:r="http://schemas.openxmlformats.org/officeDocument/2006/relationships" id="260" r:id="R75d2445c58834890"/>
-    <p:sldId xmlns:r="http://schemas.openxmlformats.org/officeDocument/2006/relationships" id="261" r:id="Rd9d92495a78f4e70"/>
-    <p:sldId xmlns:r="http://schemas.openxmlformats.org/officeDocument/2006/relationships" id="262" r:id="R28e160cc967f47a9"/>
-    <p:sldId xmlns:r="http://schemas.openxmlformats.org/officeDocument/2006/relationships" id="263" r:id="Ra4023dd70b1c40a2"/>
+    <p:sldId xmlns:r="http://schemas.openxmlformats.org/officeDocument/2006/relationships" id="256" r:id="R746bedaf8cca4d64"/>
+    <p:sldId xmlns:r="http://schemas.openxmlformats.org/officeDocument/2006/relationships" id="257" r:id="Re09063d087764131"/>
+    <p:sldId xmlns:r="http://schemas.openxmlformats.org/officeDocument/2006/relationships" id="258" r:id="R61f414ac2b5146ed"/>
+    <p:sldId xmlns:r="http://schemas.openxmlformats.org/officeDocument/2006/relationships" id="259" r:id="R05ec0631660a48a8"/>
+    <p:sldId xmlns:r="http://schemas.openxmlformats.org/officeDocument/2006/relationships" id="260" r:id="Rafe4c1ed49a94165"/>
+    <p:sldId xmlns:r="http://schemas.openxmlformats.org/officeDocument/2006/relationships" id="261" r:id="Rc423b945c9f246d7"/>
+    <p:sldId xmlns:r="http://schemas.openxmlformats.org/officeDocument/2006/relationships" id="262" r:id="R510e444c086a4fed"/>
+    <p:sldId xmlns:r="http://schemas.openxmlformats.org/officeDocument/2006/relationships" id="263" r:id="R716c46e9c6df4931"/>
   </p:sldIdLst>
   <p:sldSz cx="12192000" cy="6858000"/>
   <p:notesSz cx="6858000" cy="9144000"/>
@@ -659,7 +659,7 @@
           <a:lstStyle xmlns:a="http://schemas.openxmlformats.org/drawingml/2006/main"/>
           <a:p xmlns:a="http://schemas.openxmlformats.org/drawingml/2006/main">
             <a:r>
-              <a:t>Source: docs/evidence/shipboard-doubao/2026-09-26T17-49-25-055Z-0db01f40/production-report.json, buggy-evidence.json and corrected-evidence.json. One actual Doubao Seed 2.0 Pro call proposed nine steps covering blank-name validation, task creation and persistence. The browser executed the buggy upload and failed after reload. A prepared corrected source then passed all nine unchanged steps. These images are original DOM-rendered captures, not native screenshots. This hosted case uses a prepared correction and does not demonstrate autonomous AI repair. The separate local Codex MCP repair is documented in docs/judge-evidence/manifest.json.</a:t>
+              <a:t>Source: docs/evidence/shipboard-doubao/2026-09-26T17-49-25-055Z-0db01f40/production-report.json, buggy-evidence.json and corrected-evidence.json. One actual Doubao Seed 2.0 Pro call proposed nine steps covering blank-name validation, task creation and persistence. The browser executed the buggy upload and failed after reload. A prepared corrected source then passed all nine unchanged steps. These images are original DOM-rendered captures, not native screenshots. This hosted case uses a prepared correction and does not demonstrate autonomous AI repair. The separate local coding-agent MCP repair is documented in docs/judge-evidence/manifest.json.</a:t>
             </a:r>
           </a:p>
         </p:txBody>
@@ -729,7 +729,7 @@
           <a:lstStyle xmlns:a="http://schemas.openxmlformats.org/drawingml/2006/main"/>
           <a:p xmlns:a="http://schemas.openxmlformats.org/drawingml/2006/main">
             <a:r>
-              <a:t>Sources: docs/UPLOADED_PROJECTS.md, docs/GITHUB_IMPORT.md, docs/evidence/shipboard-doubao/2026-09-26T17-49-25-055Z-0db01f40/repair-brief.txt, apps/web/src/upload/runtime.ts, README.md section Connect a coding agent, docs/judge-evidence/manifest.json. The hosted path copies a brief for the user to paste into their coding AI; it does not wake an editor or modify a repository. The local 12-tool MCP adapter supports authorized coding agents reading evidence and rerunning the confirmed standard. The actual local source repair was performed by Codex, not Bob.</a:t>
+              <a:t>Sources: docs/UPLOADED_PROJECTS.md, docs/GITHUB_IMPORT.md, docs/evidence/shipboard-doubao/2026-09-26T17-49-25-055Z-0db01f40/repair-brief.txt, apps/web/src/upload/runtime.ts, README.md section Connect a coding agent, docs/judge-evidence/manifest.json. The hosted path copies a brief for the user to paste into their coding AI; it does not wake an editor or modify a repository. The local 12-tool MCP adapter supports authorized coding agents reading evidence and rerunning the confirmed standard. The actual local source repair used an additional coding tool after Bob helped build the initial foundations.</a:t>
             </a:r>
           </a:p>
         </p:txBody>
@@ -799,7 +799,7 @@
           <a:lstStyle xmlns:a="http://schemas.openxmlformats.org/drawingml/2006/main"/>
           <a:p xmlns:a="http://schemas.openxmlformats.org/drawingml/2006/main">
             <a:r>
-              <a:t>Original image: bob_sessions/ming_task03_stage_b_final_summary.png. Task ID bfa75e6b4e53cc8425e6754a8b69c8f3. The screenshot is a real task-consumption summary; it is not independent proof that every listed check passed. Bob contribution details and independent verification: docs/STAGE_B_RESULTS.md, docs/STAGE_C_STATUS.md, bob_sessions/README.md, bob_sessions/manifest.json. Bob implemented initial Stage A runner/service/UI, Stage B provider draft validation/confirmation, and partial Stage C repair/MCP foundations. Codex completed and extended the product after the trial quota ended. No watsonx.ai or watsonx Orchestrate was used.</a:t>
+              <a:t>Original unaltered image: bob_sessions/ming_task02_stage_a_final_summary.png. Task ID 2b41a80061020f364f496c02d0c9c5e7. This Stage A task-consumption summary records real development activity and includes a failed command. It does not independently prove that every check passed. Bob contribution details and independent verification: docs/STAGE_B_RESULTS.md, docs/STAGE_C_STATUS.md, bob_sessions/README.md, bob_sessions/manifest.json. Bob implemented the initial Stage A runner/service/UI, Stage B provider draft validation/confirmation, and partial Stage C repair/MCP foundations. Subsequent development with additional tools completed and extended the product after the trial quota ended. No watsonx.ai or watsonx Orchestrate was used.</a:t>
             </a:r>
           </a:p>
         </p:txBody>
@@ -1007,7 +1007,7 @@
   </p:cSld>
   <p:clrMap bg1="lt1" tx1="dk1" bg2="lt2" tx2="dk2" accent1="accent1" accent2="accent2" accent3="accent3" accent4="accent4" accent5="accent5" accent6="accent6" hlink="hlink" folHlink="folHlink"/>
   <p:sldLayoutIdLst>
-    <p:sldLayoutId xmlns:r="http://schemas.openxmlformats.org/officeDocument/2006/relationships" id="2147483649" r:id="R278cdfc9beb743dc"/>
+    <p:sldLayoutId xmlns:r="http://schemas.openxmlformats.org/officeDocument/2006/relationships" id="2147483649" r:id="R163b07440b5c48a3"/>
   </p:sldLayoutIdLst>
   <p:txStyles>
     <p:titleStyle>
@@ -1562,7 +1562,7 @@
           <p:nvPr/>
         </p:nvPicPr>
         <p:blipFill>
-          <a:blip xmlns:r="http://schemas.openxmlformats.org/officeDocument/2006/relationships" xmlns:a="http://schemas.openxmlformats.org/drawingml/2006/main" r:embed="Rdd3e98322adf44f5"/>
+          <a:blip xmlns:r="http://schemas.openxmlformats.org/officeDocument/2006/relationships" xmlns:a="http://schemas.openxmlformats.org/drawingml/2006/main" r:embed="Raa8a229fb784487c"/>
           <a:srcRect xmlns:a="http://schemas.openxmlformats.org/drawingml/2006/main" l="0" t="7813" r="0" b="7813"/>
           <a:stretch xmlns:a="http://schemas.openxmlformats.org/drawingml/2006/main">
             <a:fillRect l="0" t="0" r="0" b="0"/>
@@ -1583,7 +1583,7 @@
           <p:cNvPr id="2" name="text-1">
             <a:extLst xmlns:a="http://schemas.openxmlformats.org/drawingml/2006/main">
               <a:ext uri="{FF2B5EF4-FFF2-40B4-BE49-F238E27FC236}">
-                <a16:creationId xmlns:a16="http://schemas.microsoft.com/office/drawing/2014/main" id="{A9F4E8A3-DC65-4097-BCE1-80ACE6CF7D7B}"/>
+                <a16:creationId xmlns:a16="http://schemas.microsoft.com/office/drawing/2014/main" id="{D29596D3-0134-4CC9-92CD-C457D23DF608}"/>
               </a:ext>
             </a:extLst>
           </p:cNvPr>
@@ -1640,7 +1640,7 @@
           <p:cNvPr id="3" name="text-2">
             <a:extLst xmlns:a="http://schemas.openxmlformats.org/drawingml/2006/main">
               <a:ext uri="{FF2B5EF4-FFF2-40B4-BE49-F238E27FC236}">
-                <a16:creationId xmlns:a16="http://schemas.microsoft.com/office/drawing/2014/main" id="{45BF3E78-A414-45CA-B79A-C5E6B1AC54E7}"/>
+                <a16:creationId xmlns:a16="http://schemas.microsoft.com/office/drawing/2014/main" id="{35F1AAE9-7809-4F26-9C1C-0BF3EA707C07}"/>
               </a:ext>
             </a:extLst>
           </p:cNvPr>
@@ -1697,7 +1697,7 @@
           <p:cNvPr id="4" name="text-3">
             <a:extLst xmlns:a="http://schemas.openxmlformats.org/drawingml/2006/main">
               <a:ext uri="{FF2B5EF4-FFF2-40B4-BE49-F238E27FC236}">
-                <a16:creationId xmlns:a16="http://schemas.microsoft.com/office/drawing/2014/main" id="{A03FBC73-B195-4BA4-B633-8D9895D5217D}"/>
+                <a16:creationId xmlns:a16="http://schemas.microsoft.com/office/drawing/2014/main" id="{FC2DEA4D-1A21-4D4C-8AA7-4407B6E94ADD}"/>
               </a:ext>
             </a:extLst>
           </p:cNvPr>
@@ -1777,7 +1777,7 @@
           <p:cNvPr id="5" name="text-4">
             <a:extLst xmlns:a="http://schemas.openxmlformats.org/drawingml/2006/main">
               <a:ext uri="{FF2B5EF4-FFF2-40B4-BE49-F238E27FC236}">
-                <a16:creationId xmlns:a16="http://schemas.microsoft.com/office/drawing/2014/main" id="{6C7509BE-FD5D-46D9-A50C-6D7056053EDB}"/>
+                <a16:creationId xmlns:a16="http://schemas.microsoft.com/office/drawing/2014/main" id="{2E823E6B-00A6-4242-8E5A-57E577F4DC58}"/>
               </a:ext>
             </a:extLst>
           </p:cNvPr>
@@ -1832,7 +1832,7 @@
     </p:spTree>
     <p:extLst>
       <p:ext uri="{BB962C8B-B14F-4D97-AF65-F5344CB8AC3E}">
-        <p14:creationId xmlns:p14="http://schemas.microsoft.com/office/powerpoint/2010/main" val="644654516"/>
+        <p14:creationId xmlns:p14="http://schemas.microsoft.com/office/powerpoint/2010/main" val="216533832"/>
       </p:ext>
     </p:extLst>
   </p:cSld>
@@ -1863,7 +1863,7 @@
           <p:cNvPr id="14" name="text-5">
             <a:extLst xmlns:a="http://schemas.openxmlformats.org/drawingml/2006/main">
               <a:ext uri="{FF2B5EF4-FFF2-40B4-BE49-F238E27FC236}">
-                <a16:creationId xmlns:a16="http://schemas.microsoft.com/office/drawing/2014/main" id="{33927D05-E053-48D8-A971-6D66E3D250DB}"/>
+                <a16:creationId xmlns:a16="http://schemas.microsoft.com/office/drawing/2014/main" id="{0766C815-B274-4209-AB66-CBDEDF24466B}"/>
               </a:ext>
             </a:extLst>
           </p:cNvPr>
@@ -1920,7 +1920,7 @@
           <p:cNvPr id="2" name="text-6">
             <a:extLst xmlns:a="http://schemas.openxmlformats.org/drawingml/2006/main">
               <a:ext uri="{FF2B5EF4-FFF2-40B4-BE49-F238E27FC236}">
-                <a16:creationId xmlns:a16="http://schemas.microsoft.com/office/drawing/2014/main" id="{3C74328D-4C43-4C8C-A71D-987A3F91F7A1}"/>
+                <a16:creationId xmlns:a16="http://schemas.microsoft.com/office/drawing/2014/main" id="{0A0B7C36-C6C6-4BA9-A287-EADEE041AF98}"/>
               </a:ext>
             </a:extLst>
           </p:cNvPr>
@@ -1977,7 +1977,7 @@
           <p:cNvPr id="3" name="text-7">
             <a:extLst xmlns:a="http://schemas.openxmlformats.org/drawingml/2006/main">
               <a:ext uri="{FF2B5EF4-FFF2-40B4-BE49-F238E27FC236}">
-                <a16:creationId xmlns:a16="http://schemas.microsoft.com/office/drawing/2014/main" id="{F55D98B7-23E7-4916-B564-85CC972D822A}"/>
+                <a16:creationId xmlns:a16="http://schemas.microsoft.com/office/drawing/2014/main" id="{782E397B-3A52-41D8-9168-297119395422}"/>
               </a:ext>
             </a:extLst>
           </p:cNvPr>
@@ -2034,7 +2034,7 @@
           <p:cNvPr id="4" name="text-8">
             <a:extLst xmlns:a="http://schemas.openxmlformats.org/drawingml/2006/main">
               <a:ext uri="{FF2B5EF4-FFF2-40B4-BE49-F238E27FC236}">
-                <a16:creationId xmlns:a16="http://schemas.microsoft.com/office/drawing/2014/main" id="{22A9F7B9-CE86-4FF1-AFF0-AE9601034088}"/>
+                <a16:creationId xmlns:a16="http://schemas.microsoft.com/office/drawing/2014/main" id="{16E14273-6E02-4125-ABAF-B7083C4E84C6}"/>
               </a:ext>
             </a:extLst>
           </p:cNvPr>
@@ -2114,7 +2114,7 @@
           <p:cNvPr id="5" name="text-9">
             <a:extLst xmlns:a="http://schemas.openxmlformats.org/drawingml/2006/main">
               <a:ext uri="{FF2B5EF4-FFF2-40B4-BE49-F238E27FC236}">
-                <a16:creationId xmlns:a16="http://schemas.microsoft.com/office/drawing/2014/main" id="{28E97272-42F8-45D8-A60E-4CDACD05A909}"/>
+                <a16:creationId xmlns:a16="http://schemas.microsoft.com/office/drawing/2014/main" id="{192BBC61-D031-4A18-9A86-CEAC08EFF2A5}"/>
               </a:ext>
             </a:extLst>
           </p:cNvPr>
@@ -2194,7 +2194,7 @@
           <p:cNvPr id="6" name="text-10">
             <a:extLst xmlns:a="http://schemas.openxmlformats.org/drawingml/2006/main">
               <a:ext uri="{FF2B5EF4-FFF2-40B4-BE49-F238E27FC236}">
-                <a16:creationId xmlns:a16="http://schemas.microsoft.com/office/drawing/2014/main" id="{2870D2EC-E199-4C3F-A51F-893BF746CED6}"/>
+                <a16:creationId xmlns:a16="http://schemas.microsoft.com/office/drawing/2014/main" id="{F9BF82A4-9A40-4432-B550-14DC068EC91B}"/>
               </a:ext>
             </a:extLst>
           </p:cNvPr>
@@ -2251,7 +2251,7 @@
           <p:cNvPr id="7" name="text-11">
             <a:extLst xmlns:a="http://schemas.openxmlformats.org/drawingml/2006/main">
               <a:ext uri="{FF2B5EF4-FFF2-40B4-BE49-F238E27FC236}">
-                <a16:creationId xmlns:a16="http://schemas.microsoft.com/office/drawing/2014/main" id="{CA3FDA40-1D5D-437A-AC6B-7A19F66C9AC5}"/>
+                <a16:creationId xmlns:a16="http://schemas.microsoft.com/office/drawing/2014/main" id="{A409AEB7-B95B-41B8-BEB9-783EE9DA7541}"/>
               </a:ext>
             </a:extLst>
           </p:cNvPr>
@@ -2308,7 +2308,7 @@
           <p:cNvPr id="8" name="text-12">
             <a:extLst xmlns:a="http://schemas.openxmlformats.org/drawingml/2006/main">
               <a:ext uri="{FF2B5EF4-FFF2-40B4-BE49-F238E27FC236}">
-                <a16:creationId xmlns:a16="http://schemas.microsoft.com/office/drawing/2014/main" id="{FF51B09B-21A8-4CD8-B19F-4341DCA97B01}"/>
+                <a16:creationId xmlns:a16="http://schemas.microsoft.com/office/drawing/2014/main" id="{2AC7C2FC-90A2-40D9-A7FD-52F8E06E88DB}"/>
               </a:ext>
             </a:extLst>
           </p:cNvPr>
@@ -2365,7 +2365,7 @@
           <p:cNvPr id="9" name="text-13">
             <a:extLst xmlns:a="http://schemas.openxmlformats.org/drawingml/2006/main">
               <a:ext uri="{FF2B5EF4-FFF2-40B4-BE49-F238E27FC236}">
-                <a16:creationId xmlns:a16="http://schemas.microsoft.com/office/drawing/2014/main" id="{D05A684A-F944-4D79-BBEB-0497D73E6950}"/>
+                <a16:creationId xmlns:a16="http://schemas.microsoft.com/office/drawing/2014/main" id="{2A1CD74D-4599-49B9-80C2-AFE7527C9344}"/>
               </a:ext>
             </a:extLst>
           </p:cNvPr>
@@ -2422,7 +2422,7 @@
           <p:cNvPr id="10" name="text-14">
             <a:extLst xmlns:a="http://schemas.openxmlformats.org/drawingml/2006/main">
               <a:ext uri="{FF2B5EF4-FFF2-40B4-BE49-F238E27FC236}">
-                <a16:creationId xmlns:a16="http://schemas.microsoft.com/office/drawing/2014/main" id="{CF010DDA-20FA-42CD-B7F7-204AC1A8327A}"/>
+                <a16:creationId xmlns:a16="http://schemas.microsoft.com/office/drawing/2014/main" id="{B44737B6-1152-45F7-A740-2E842B2EDA25}"/>
               </a:ext>
             </a:extLst>
           </p:cNvPr>
@@ -2479,7 +2479,7 @@
           <p:cNvPr id="11" name="text-15">
             <a:extLst xmlns:a="http://schemas.openxmlformats.org/drawingml/2006/main">
               <a:ext uri="{FF2B5EF4-FFF2-40B4-BE49-F238E27FC236}">
-                <a16:creationId xmlns:a16="http://schemas.microsoft.com/office/drawing/2014/main" id="{DF40473F-3C87-4D97-9F52-0E2503CC11E5}"/>
+                <a16:creationId xmlns:a16="http://schemas.microsoft.com/office/drawing/2014/main" id="{02075CE7-273A-4029-8831-62D4F1657EF0}"/>
               </a:ext>
             </a:extLst>
           </p:cNvPr>
@@ -2536,7 +2536,7 @@
           <p:cNvPr id="12" name="text-16">
             <a:extLst xmlns:a="http://schemas.openxmlformats.org/drawingml/2006/main">
               <a:ext uri="{FF2B5EF4-FFF2-40B4-BE49-F238E27FC236}">
-                <a16:creationId xmlns:a16="http://schemas.microsoft.com/office/drawing/2014/main" id="{3208FA57-1D36-43AD-A4B3-F0EB33AB26AD}"/>
+                <a16:creationId xmlns:a16="http://schemas.microsoft.com/office/drawing/2014/main" id="{31EEF65A-B832-46C6-A09C-8D4586BF6FD2}"/>
               </a:ext>
             </a:extLst>
           </p:cNvPr>
@@ -2593,7 +2593,7 @@
           <p:cNvPr id="13" name="text-17">
             <a:extLst xmlns:a="http://schemas.openxmlformats.org/drawingml/2006/main">
               <a:ext uri="{FF2B5EF4-FFF2-40B4-BE49-F238E27FC236}">
-                <a16:creationId xmlns:a16="http://schemas.microsoft.com/office/drawing/2014/main" id="{B92464F6-652E-4A84-802F-C388475A902D}"/>
+                <a16:creationId xmlns:a16="http://schemas.microsoft.com/office/drawing/2014/main" id="{58C3967B-3070-4C6E-9446-224A3C446AD4}"/>
               </a:ext>
             </a:extLst>
           </p:cNvPr>
@@ -2648,7 +2648,7 @@
     </p:spTree>
     <p:extLst>
       <p:ext uri="{BB962C8B-B14F-4D97-AF65-F5344CB8AC3E}">
-        <p14:creationId xmlns:p14="http://schemas.microsoft.com/office/powerpoint/2010/main" val="1243025597"/>
+        <p14:creationId xmlns:p14="http://schemas.microsoft.com/office/powerpoint/2010/main" val="1974661523"/>
       </p:ext>
     </p:extLst>
   </p:cSld>
@@ -2679,7 +2679,7 @@
           <p:cNvPr id="13" name="text-18">
             <a:extLst xmlns:a="http://schemas.openxmlformats.org/drawingml/2006/main">
               <a:ext uri="{FF2B5EF4-FFF2-40B4-BE49-F238E27FC236}">
-                <a16:creationId xmlns:a16="http://schemas.microsoft.com/office/drawing/2014/main" id="{F40B7FF3-BEF5-4F6A-9AC7-525B8E709451}"/>
+                <a16:creationId xmlns:a16="http://schemas.microsoft.com/office/drawing/2014/main" id="{24585471-9656-41BC-811B-AE068FB282F2}"/>
               </a:ext>
             </a:extLst>
           </p:cNvPr>
@@ -2736,7 +2736,7 @@
           <p:cNvPr id="2" name="text-19">
             <a:extLst xmlns:a="http://schemas.openxmlformats.org/drawingml/2006/main">
               <a:ext uri="{FF2B5EF4-FFF2-40B4-BE49-F238E27FC236}">
-                <a16:creationId xmlns:a16="http://schemas.microsoft.com/office/drawing/2014/main" id="{A8DDEA28-D7DF-42AC-9CD6-D62A17EAF800}"/>
+                <a16:creationId xmlns:a16="http://schemas.microsoft.com/office/drawing/2014/main" id="{C6F8B035-5F55-4D36-9132-83820F0F5B2C}"/>
               </a:ext>
             </a:extLst>
           </p:cNvPr>
@@ -2793,7 +2793,7 @@
           <p:cNvPr id="3" name="text-20">
             <a:extLst xmlns:a="http://schemas.openxmlformats.org/drawingml/2006/main">
               <a:ext uri="{FF2B5EF4-FFF2-40B4-BE49-F238E27FC236}">
-                <a16:creationId xmlns:a16="http://schemas.microsoft.com/office/drawing/2014/main" id="{A0B39F6B-D46F-4032-90F1-20CD872878A4}"/>
+                <a16:creationId xmlns:a16="http://schemas.microsoft.com/office/drawing/2014/main" id="{6F0130FC-1D2A-488F-9692-B09C706A183F}"/>
               </a:ext>
             </a:extLst>
           </p:cNvPr>
@@ -2850,7 +2850,7 @@
           <p:cNvPr id="4" name="text-21">
             <a:extLst xmlns:a="http://schemas.openxmlformats.org/drawingml/2006/main">
               <a:ext uri="{FF2B5EF4-FFF2-40B4-BE49-F238E27FC236}">
-                <a16:creationId xmlns:a16="http://schemas.microsoft.com/office/drawing/2014/main" id="{AF376235-CA97-475C-B06D-CC1662EA00CD}"/>
+                <a16:creationId xmlns:a16="http://schemas.microsoft.com/office/drawing/2014/main" id="{4D164786-327C-45F3-B655-EAB3BC69E2A6}"/>
               </a:ext>
             </a:extLst>
           </p:cNvPr>
@@ -2907,7 +2907,7 @@
           <p:cNvPr id="5" name="text-22">
             <a:extLst xmlns:a="http://schemas.openxmlformats.org/drawingml/2006/main">
               <a:ext uri="{FF2B5EF4-FFF2-40B4-BE49-F238E27FC236}">
-                <a16:creationId xmlns:a16="http://schemas.microsoft.com/office/drawing/2014/main" id="{E7C73292-2971-47D6-9EF8-8E418B030D50}"/>
+                <a16:creationId xmlns:a16="http://schemas.microsoft.com/office/drawing/2014/main" id="{A1B7115F-43FD-43F7-90DC-BDD0CC951E44}"/>
               </a:ext>
             </a:extLst>
           </p:cNvPr>
@@ -2987,7 +2987,7 @@
           <p:cNvPr id="6" name="text-23">
             <a:extLst xmlns:a="http://schemas.openxmlformats.org/drawingml/2006/main">
               <a:ext uri="{FF2B5EF4-FFF2-40B4-BE49-F238E27FC236}">
-                <a16:creationId xmlns:a16="http://schemas.microsoft.com/office/drawing/2014/main" id="{FE52BA9A-F9F2-456E-AB4E-EA1D7511C119}"/>
+                <a16:creationId xmlns:a16="http://schemas.microsoft.com/office/drawing/2014/main" id="{66558CDE-2B0F-468F-B9BD-DD50DA96BAF7}"/>
               </a:ext>
             </a:extLst>
           </p:cNvPr>
@@ -3044,7 +3044,7 @@
           <p:cNvPr id="7" name="text-24">
             <a:extLst xmlns:a="http://schemas.openxmlformats.org/drawingml/2006/main">
               <a:ext uri="{FF2B5EF4-FFF2-40B4-BE49-F238E27FC236}">
-                <a16:creationId xmlns:a16="http://schemas.microsoft.com/office/drawing/2014/main" id="{83FE0B3B-A6C7-4AE6-A664-F3B8F4F5574E}"/>
+                <a16:creationId xmlns:a16="http://schemas.microsoft.com/office/drawing/2014/main" id="{79F9A545-9B55-4900-955B-697E8A24B577}"/>
               </a:ext>
             </a:extLst>
           </p:cNvPr>
@@ -3124,7 +3124,7 @@
           <p:cNvPr id="8" name="text-25">
             <a:extLst xmlns:a="http://schemas.openxmlformats.org/drawingml/2006/main">
               <a:ext uri="{FF2B5EF4-FFF2-40B4-BE49-F238E27FC236}">
-                <a16:creationId xmlns:a16="http://schemas.microsoft.com/office/drawing/2014/main" id="{7A412349-0793-40D9-883E-E5D77E9656EA}"/>
+                <a16:creationId xmlns:a16="http://schemas.microsoft.com/office/drawing/2014/main" id="{7C865119-F539-4AD8-9E99-FDEB26CD3D01}"/>
               </a:ext>
             </a:extLst>
           </p:cNvPr>
@@ -3181,7 +3181,7 @@
           <p:cNvPr id="9" name="text-26">
             <a:extLst xmlns:a="http://schemas.openxmlformats.org/drawingml/2006/main">
               <a:ext uri="{FF2B5EF4-FFF2-40B4-BE49-F238E27FC236}">
-                <a16:creationId xmlns:a16="http://schemas.microsoft.com/office/drawing/2014/main" id="{BCC832B0-6515-4BF2-AB18-C7BEA58C9488}"/>
+                <a16:creationId xmlns:a16="http://schemas.microsoft.com/office/drawing/2014/main" id="{E9E3F575-D980-4A08-A785-43F935169E4B}"/>
               </a:ext>
             </a:extLst>
           </p:cNvPr>
@@ -3261,7 +3261,7 @@
           <p:cNvPr id="10" name="text-27">
             <a:extLst xmlns:a="http://schemas.openxmlformats.org/drawingml/2006/main">
               <a:ext uri="{FF2B5EF4-FFF2-40B4-BE49-F238E27FC236}">
-                <a16:creationId xmlns:a16="http://schemas.microsoft.com/office/drawing/2014/main" id="{1E725A1C-B0B9-4522-A29E-27EA986AF4F2}"/>
+                <a16:creationId xmlns:a16="http://schemas.microsoft.com/office/drawing/2014/main" id="{66841827-F707-43EE-82F8-3D06D5E0A79C}"/>
               </a:ext>
             </a:extLst>
           </p:cNvPr>
@@ -3318,7 +3318,7 @@
           <p:cNvPr id="11" name="text-28">
             <a:extLst xmlns:a="http://schemas.openxmlformats.org/drawingml/2006/main">
               <a:ext uri="{FF2B5EF4-FFF2-40B4-BE49-F238E27FC236}">
-                <a16:creationId xmlns:a16="http://schemas.microsoft.com/office/drawing/2014/main" id="{440982F2-2179-48DF-A7C9-0FB8D83A7EAB}"/>
+                <a16:creationId xmlns:a16="http://schemas.microsoft.com/office/drawing/2014/main" id="{25C3F609-8C32-4910-AC6D-780133727CB0}"/>
               </a:ext>
             </a:extLst>
           </p:cNvPr>
@@ -3402,7 +3402,7 @@
           <p:nvPr/>
         </p:nvPicPr>
         <p:blipFill>
-          <a:blip xmlns:r="http://schemas.openxmlformats.org/officeDocument/2006/relationships" xmlns:a="http://schemas.openxmlformats.org/drawingml/2006/main" r:embed="Rfbc10fb80d9c4815"/>
+          <a:blip xmlns:r="http://schemas.openxmlformats.org/officeDocument/2006/relationships" xmlns:a="http://schemas.openxmlformats.org/drawingml/2006/main" r:embed="R419509b887dc4154"/>
           <a:stretch xmlns:a="http://schemas.openxmlformats.org/drawingml/2006/main"/>
         </p:blipFill>
         <p:spPr>
@@ -3418,7 +3418,7 @@
     </p:spTree>
     <p:extLst>
       <p:ext uri="{BB962C8B-B14F-4D97-AF65-F5344CB8AC3E}">
-        <p14:creationId xmlns:p14="http://schemas.microsoft.com/office/powerpoint/2010/main" val="948558505"/>
+        <p14:creationId xmlns:p14="http://schemas.microsoft.com/office/powerpoint/2010/main" val="1074413426"/>
       </p:ext>
     </p:extLst>
   </p:cSld>
@@ -3449,7 +3449,7 @@
           <p:cNvPr id="12" name="text-29">
             <a:extLst xmlns:a="http://schemas.openxmlformats.org/drawingml/2006/main">
               <a:ext uri="{FF2B5EF4-FFF2-40B4-BE49-F238E27FC236}">
-                <a16:creationId xmlns:a16="http://schemas.microsoft.com/office/drawing/2014/main" id="{658434A5-83E9-478C-AC8C-D69E78592BED}"/>
+                <a16:creationId xmlns:a16="http://schemas.microsoft.com/office/drawing/2014/main" id="{885B8947-D6A9-455E-B2B6-844AEDAFC22D}"/>
               </a:ext>
             </a:extLst>
           </p:cNvPr>
@@ -3506,7 +3506,7 @@
           <p:cNvPr id="2" name="text-30">
             <a:extLst xmlns:a="http://schemas.openxmlformats.org/drawingml/2006/main">
               <a:ext uri="{FF2B5EF4-FFF2-40B4-BE49-F238E27FC236}">
-                <a16:creationId xmlns:a16="http://schemas.microsoft.com/office/drawing/2014/main" id="{E9C30EA0-77AC-4447-9F67-BEEEDEF607BD}"/>
+                <a16:creationId xmlns:a16="http://schemas.microsoft.com/office/drawing/2014/main" id="{5E22D063-7B12-43EA-9572-668A8DC3397E}"/>
               </a:ext>
             </a:extLst>
           </p:cNvPr>
@@ -3563,7 +3563,7 @@
           <p:cNvPr id="3" name="text-31">
             <a:extLst xmlns:a="http://schemas.openxmlformats.org/drawingml/2006/main">
               <a:ext uri="{FF2B5EF4-FFF2-40B4-BE49-F238E27FC236}">
-                <a16:creationId xmlns:a16="http://schemas.microsoft.com/office/drawing/2014/main" id="{C4298B45-C3C9-412F-AEFB-968B48659600}"/>
+                <a16:creationId xmlns:a16="http://schemas.microsoft.com/office/drawing/2014/main" id="{D5EA379F-869D-476D-B747-24F091AEC327}"/>
               </a:ext>
             </a:extLst>
           </p:cNvPr>
@@ -3620,7 +3620,7 @@
           <p:cNvPr id="4" name="text-32">
             <a:extLst xmlns:a="http://schemas.openxmlformats.org/drawingml/2006/main">
               <a:ext uri="{FF2B5EF4-FFF2-40B4-BE49-F238E27FC236}">
-                <a16:creationId xmlns:a16="http://schemas.microsoft.com/office/drawing/2014/main" id="{46A27549-F59A-4947-A12E-65FBC26E020E}"/>
+                <a16:creationId xmlns:a16="http://schemas.microsoft.com/office/drawing/2014/main" id="{2BF607D9-A9E3-4B12-8191-9F71C15506A4}"/>
               </a:ext>
             </a:extLst>
           </p:cNvPr>
@@ -3677,7 +3677,7 @@
           <p:cNvPr id="5" name="text-33">
             <a:extLst xmlns:a="http://schemas.openxmlformats.org/drawingml/2006/main">
               <a:ext uri="{FF2B5EF4-FFF2-40B4-BE49-F238E27FC236}">
-                <a16:creationId xmlns:a16="http://schemas.microsoft.com/office/drawing/2014/main" id="{2664ED40-CB78-44D8-9842-1599AFE8FEF4}"/>
+                <a16:creationId xmlns:a16="http://schemas.microsoft.com/office/drawing/2014/main" id="{511B94A4-99D1-4D09-B1EF-E89E410F7F80}"/>
               </a:ext>
             </a:extLst>
           </p:cNvPr>
@@ -3738,7 +3738,7 @@
           <p:nvPr/>
         </p:nvPicPr>
         <p:blipFill>
-          <a:blip xmlns:r="http://schemas.openxmlformats.org/officeDocument/2006/relationships" xmlns:a="http://schemas.openxmlformats.org/drawingml/2006/main" r:embed="R1e008b3c89b4487d"/>
+          <a:blip xmlns:r="http://schemas.openxmlformats.org/officeDocument/2006/relationships" xmlns:a="http://schemas.openxmlformats.org/drawingml/2006/main" r:embed="Rb8c35f8f18724023"/>
           <a:stretch xmlns:a="http://schemas.openxmlformats.org/drawingml/2006/main"/>
         </p:blipFill>
         <p:spPr>
@@ -3760,7 +3760,7 @@
           <p:nvPr/>
         </p:nvPicPr>
         <p:blipFill>
-          <a:blip xmlns:r="http://schemas.openxmlformats.org/officeDocument/2006/relationships" xmlns:a="http://schemas.openxmlformats.org/drawingml/2006/main" r:embed="Rbd99aa29d34a4283"/>
+          <a:blip xmlns:r="http://schemas.openxmlformats.org/officeDocument/2006/relationships" xmlns:a="http://schemas.openxmlformats.org/drawingml/2006/main" r:embed="R39850ed3357344cc"/>
           <a:stretch xmlns:a="http://schemas.openxmlformats.org/drawingml/2006/main"/>
         </p:blipFill>
         <p:spPr>
@@ -3778,7 +3778,7 @@
           <p:cNvPr id="8" name="text-34">
             <a:extLst xmlns:a="http://schemas.openxmlformats.org/drawingml/2006/main">
               <a:ext uri="{FF2B5EF4-FFF2-40B4-BE49-F238E27FC236}">
-                <a16:creationId xmlns:a16="http://schemas.microsoft.com/office/drawing/2014/main" id="{1F7FA854-AC5A-4AE3-B745-82309786FF55}"/>
+                <a16:creationId xmlns:a16="http://schemas.microsoft.com/office/drawing/2014/main" id="{42B010AF-85B0-455B-A0CC-610F609C7E8B}"/>
               </a:ext>
             </a:extLst>
           </p:cNvPr>
@@ -3835,7 +3835,7 @@
           <p:cNvPr id="9" name="text-35">
             <a:extLst xmlns:a="http://schemas.openxmlformats.org/drawingml/2006/main">
               <a:ext uri="{FF2B5EF4-FFF2-40B4-BE49-F238E27FC236}">
-                <a16:creationId xmlns:a16="http://schemas.microsoft.com/office/drawing/2014/main" id="{4B07FC39-7CDF-4424-8E70-631E85CAEC9F}"/>
+                <a16:creationId xmlns:a16="http://schemas.microsoft.com/office/drawing/2014/main" id="{D788E7F7-B13F-4087-A807-9EB4637ABA64}"/>
               </a:ext>
             </a:extLst>
           </p:cNvPr>
@@ -3892,7 +3892,7 @@
           <p:cNvPr id="10" name="text-36">
             <a:extLst xmlns:a="http://schemas.openxmlformats.org/drawingml/2006/main">
               <a:ext uri="{FF2B5EF4-FFF2-40B4-BE49-F238E27FC236}">
-                <a16:creationId xmlns:a16="http://schemas.microsoft.com/office/drawing/2014/main" id="{4B090C2B-DEFB-4C30-91FA-54949593715C}"/>
+                <a16:creationId xmlns:a16="http://schemas.microsoft.com/office/drawing/2014/main" id="{38AEDDC4-8E90-41F1-8065-53A70F3FF85D}"/>
               </a:ext>
             </a:extLst>
           </p:cNvPr>
@@ -3995,7 +3995,7 @@
           <p:cNvPr id="11" name="text-37">
             <a:extLst xmlns:a="http://schemas.openxmlformats.org/drawingml/2006/main">
               <a:ext uri="{FF2B5EF4-FFF2-40B4-BE49-F238E27FC236}">
-                <a16:creationId xmlns:a16="http://schemas.microsoft.com/office/drawing/2014/main" id="{16D7D61C-1CA1-49B2-A5F2-36EFD33C94F6}"/>
+                <a16:creationId xmlns:a16="http://schemas.microsoft.com/office/drawing/2014/main" id="{6F48A399-8983-4718-AFD7-7CFE6688592C}"/>
               </a:ext>
             </a:extLst>
           </p:cNvPr>
@@ -4050,7 +4050,7 @@
     </p:spTree>
     <p:extLst>
       <p:ext uri="{BB962C8B-B14F-4D97-AF65-F5344CB8AC3E}">
-        <p14:creationId xmlns:p14="http://schemas.microsoft.com/office/powerpoint/2010/main" val="1386490431"/>
+        <p14:creationId xmlns:p14="http://schemas.microsoft.com/office/powerpoint/2010/main" val="369867591"/>
       </p:ext>
     </p:extLst>
   </p:cSld>
@@ -4081,7 +4081,7 @@
           <p:cNvPr id="10" name="text-38">
             <a:extLst xmlns:a="http://schemas.openxmlformats.org/drawingml/2006/main">
               <a:ext uri="{FF2B5EF4-FFF2-40B4-BE49-F238E27FC236}">
-                <a16:creationId xmlns:a16="http://schemas.microsoft.com/office/drawing/2014/main" id="{1EC60921-6E67-4798-B40E-A8C68B5D4FD1}"/>
+                <a16:creationId xmlns:a16="http://schemas.microsoft.com/office/drawing/2014/main" id="{A8B54163-EFBC-4514-B88B-F378A8BCF8F1}"/>
               </a:ext>
             </a:extLst>
           </p:cNvPr>
@@ -4138,7 +4138,7 @@
           <p:cNvPr id="2" name="text-39">
             <a:extLst xmlns:a="http://schemas.openxmlformats.org/drawingml/2006/main">
               <a:ext uri="{FF2B5EF4-FFF2-40B4-BE49-F238E27FC236}">
-                <a16:creationId xmlns:a16="http://schemas.microsoft.com/office/drawing/2014/main" id="{D38D3DDB-8EB7-4FBB-9F0B-9DC3027D4135}"/>
+                <a16:creationId xmlns:a16="http://schemas.microsoft.com/office/drawing/2014/main" id="{B363FB7F-8F7A-4C30-8269-660F36F8FB0C}"/>
               </a:ext>
             </a:extLst>
           </p:cNvPr>
@@ -4195,7 +4195,7 @@
           <p:cNvPr id="3" name="text-40">
             <a:extLst xmlns:a="http://schemas.openxmlformats.org/drawingml/2006/main">
               <a:ext uri="{FF2B5EF4-FFF2-40B4-BE49-F238E27FC236}">
-                <a16:creationId xmlns:a16="http://schemas.microsoft.com/office/drawing/2014/main" id="{84493DE2-5638-40C8-85ED-E2F78FF2C6FE}"/>
+                <a16:creationId xmlns:a16="http://schemas.microsoft.com/office/drawing/2014/main" id="{1A563B90-93B1-471C-B5BF-66008D976AB6}"/>
               </a:ext>
             </a:extLst>
           </p:cNvPr>
@@ -4252,7 +4252,7 @@
           <p:cNvPr id="4" name="text-41">
             <a:extLst xmlns:a="http://schemas.openxmlformats.org/drawingml/2006/main">
               <a:ext uri="{FF2B5EF4-FFF2-40B4-BE49-F238E27FC236}">
-                <a16:creationId xmlns:a16="http://schemas.microsoft.com/office/drawing/2014/main" id="{C2A7D8AA-2E65-4B49-8BE7-416C67822A00}"/>
+                <a16:creationId xmlns:a16="http://schemas.microsoft.com/office/drawing/2014/main" id="{2F21E7F2-CC60-45BE-919C-F3D0101A4286}"/>
               </a:ext>
             </a:extLst>
           </p:cNvPr>
@@ -4309,7 +4309,7 @@
           <p:cNvPr id="5" name="text-42">
             <a:extLst xmlns:a="http://schemas.openxmlformats.org/drawingml/2006/main">
               <a:ext uri="{FF2B5EF4-FFF2-40B4-BE49-F238E27FC236}">
-                <a16:creationId xmlns:a16="http://schemas.microsoft.com/office/drawing/2014/main" id="{82E5F5A1-4B53-46CF-8EE7-3BBFF42EC3EA}"/>
+                <a16:creationId xmlns:a16="http://schemas.microsoft.com/office/drawing/2014/main" id="{A531678E-EF46-4895-8278-5C5D632B090D}"/>
               </a:ext>
             </a:extLst>
           </p:cNvPr>
@@ -4435,7 +4435,7 @@
           <p:cNvPr id="6" name="text-43">
             <a:extLst xmlns:a="http://schemas.openxmlformats.org/drawingml/2006/main">
               <a:ext uri="{FF2B5EF4-FFF2-40B4-BE49-F238E27FC236}">
-                <a16:creationId xmlns:a16="http://schemas.microsoft.com/office/drawing/2014/main" id="{0BBD540D-0348-4466-A264-B1812B4E1BA9}"/>
+                <a16:creationId xmlns:a16="http://schemas.microsoft.com/office/drawing/2014/main" id="{BF454E74-E5A1-4129-B1DB-E82018915DF3}"/>
               </a:ext>
             </a:extLst>
           </p:cNvPr>
@@ -4492,7 +4492,7 @@
           <p:cNvPr id="7" name="text-44">
             <a:extLst xmlns:a="http://schemas.openxmlformats.org/drawingml/2006/main">
               <a:ext uri="{FF2B5EF4-FFF2-40B4-BE49-F238E27FC236}">
-                <a16:creationId xmlns:a16="http://schemas.microsoft.com/office/drawing/2014/main" id="{76165E5C-7A40-426E-86F8-507757A82925}"/>
+                <a16:creationId xmlns:a16="http://schemas.microsoft.com/office/drawing/2014/main" id="{4E27F6F5-4A2E-4190-8E15-D0AE71DFABE1}"/>
               </a:ext>
             </a:extLst>
           </p:cNvPr>
@@ -4595,7 +4595,7 @@
           <p:cNvPr id="8" name="text-45">
             <a:extLst xmlns:a="http://schemas.openxmlformats.org/drawingml/2006/main">
               <a:ext uri="{FF2B5EF4-FFF2-40B4-BE49-F238E27FC236}">
-                <a16:creationId xmlns:a16="http://schemas.microsoft.com/office/drawing/2014/main" id="{77732A76-E622-4ACD-85A6-956348298280}"/>
+                <a16:creationId xmlns:a16="http://schemas.microsoft.com/office/drawing/2014/main" id="{324337EC-50B2-43D5-A0D3-40E05AC9D0C3}"/>
               </a:ext>
             </a:extLst>
           </p:cNvPr>
@@ -4652,7 +4652,7 @@
           <p:cNvPr id="9" name="text-46">
             <a:extLst xmlns:a="http://schemas.openxmlformats.org/drawingml/2006/main">
               <a:ext uri="{FF2B5EF4-FFF2-40B4-BE49-F238E27FC236}">
-                <a16:creationId xmlns:a16="http://schemas.microsoft.com/office/drawing/2014/main" id="{A02DA655-ACEE-44E8-A95A-442AAF26A184}"/>
+                <a16:creationId xmlns:a16="http://schemas.microsoft.com/office/drawing/2014/main" id="{54E4CF9D-B2DE-4AE0-9D61-D4DA9E3D26EE}"/>
               </a:ext>
             </a:extLst>
           </p:cNvPr>
@@ -4753,7 +4753,7 @@
     </p:spTree>
     <p:extLst>
       <p:ext uri="{BB962C8B-B14F-4D97-AF65-F5344CB8AC3E}">
-        <p14:creationId xmlns:p14="http://schemas.microsoft.com/office/powerpoint/2010/main" val="221190861"/>
+        <p14:creationId xmlns:p14="http://schemas.microsoft.com/office/powerpoint/2010/main" val="1373970959"/>
       </p:ext>
     </p:extLst>
   </p:cSld>
@@ -4784,7 +4784,7 @@
           <p:cNvPr id="9" name="text-47">
             <a:extLst xmlns:a="http://schemas.openxmlformats.org/drawingml/2006/main">
               <a:ext uri="{FF2B5EF4-FFF2-40B4-BE49-F238E27FC236}">
-                <a16:creationId xmlns:a16="http://schemas.microsoft.com/office/drawing/2014/main" id="{964DB900-BCB1-4B75-9C11-9800701CB4CD}"/>
+                <a16:creationId xmlns:a16="http://schemas.microsoft.com/office/drawing/2014/main" id="{96267F9E-37ED-4BAF-A7DA-BF53BC754F7C}"/>
               </a:ext>
             </a:extLst>
           </p:cNvPr>
@@ -4841,7 +4841,7 @@
           <p:cNvPr id="2" name="text-48">
             <a:extLst xmlns:a="http://schemas.openxmlformats.org/drawingml/2006/main">
               <a:ext uri="{FF2B5EF4-FFF2-40B4-BE49-F238E27FC236}">
-                <a16:creationId xmlns:a16="http://schemas.microsoft.com/office/drawing/2014/main" id="{6F2DBECF-F8A1-4E87-BAE7-80581759F9D4}"/>
+                <a16:creationId xmlns:a16="http://schemas.microsoft.com/office/drawing/2014/main" id="{7EE5CF98-C41A-4684-BD97-5E2CA6AC3B61}"/>
               </a:ext>
             </a:extLst>
           </p:cNvPr>
@@ -4898,7 +4898,7 @@
           <p:cNvPr id="3" name="text-49">
             <a:extLst xmlns:a="http://schemas.openxmlformats.org/drawingml/2006/main">
               <a:ext uri="{FF2B5EF4-FFF2-40B4-BE49-F238E27FC236}">
-                <a16:creationId xmlns:a16="http://schemas.microsoft.com/office/drawing/2014/main" id="{D94BC497-BCBE-4606-A66B-49955F654A84}"/>
+                <a16:creationId xmlns:a16="http://schemas.microsoft.com/office/drawing/2014/main" id="{5A56C140-75D0-4540-B64D-4F4B5D5D89DC}"/>
               </a:ext>
             </a:extLst>
           </p:cNvPr>
@@ -4955,7 +4955,7 @@
           <p:cNvPr id="4" name="text-50">
             <a:extLst xmlns:a="http://schemas.openxmlformats.org/drawingml/2006/main">
               <a:ext uri="{FF2B5EF4-FFF2-40B4-BE49-F238E27FC236}">
-                <a16:creationId xmlns:a16="http://schemas.microsoft.com/office/drawing/2014/main" id="{00DAD8EE-DC3E-4F00-B45A-45F8DFDF28BA}"/>
+                <a16:creationId xmlns:a16="http://schemas.microsoft.com/office/drawing/2014/main" id="{A60B1DD6-038B-4B0F-B8F2-BCC1753F9508}"/>
               </a:ext>
             </a:extLst>
           </p:cNvPr>
@@ -5035,7 +5035,7 @@
           <p:cNvPr id="5" name="text-51">
             <a:extLst xmlns:a="http://schemas.openxmlformats.org/drawingml/2006/main">
               <a:ext uri="{FF2B5EF4-FFF2-40B4-BE49-F238E27FC236}">
-                <a16:creationId xmlns:a16="http://schemas.microsoft.com/office/drawing/2014/main" id="{BDBFB13A-2F97-43D5-AFAF-84BD24342098}"/>
+                <a16:creationId xmlns:a16="http://schemas.microsoft.com/office/drawing/2014/main" id="{A51B8843-5E7B-42AE-9A3C-EEC865F4B918}"/>
               </a:ext>
             </a:extLst>
           </p:cNvPr>
@@ -5115,7 +5115,7 @@
           <p:cNvPr id="6" name="text-52">
             <a:extLst xmlns:a="http://schemas.openxmlformats.org/drawingml/2006/main">
               <a:ext uri="{FF2B5EF4-FFF2-40B4-BE49-F238E27FC236}">
-                <a16:creationId xmlns:a16="http://schemas.microsoft.com/office/drawing/2014/main" id="{340CB6F3-DFCE-4CAB-9583-FD6C2B3BA31C}"/>
+                <a16:creationId xmlns:a16="http://schemas.microsoft.com/office/drawing/2014/main" id="{C0ECB6D0-CE6B-4E3B-8794-FA9AB02597B2}"/>
               </a:ext>
             </a:extLst>
           </p:cNvPr>
@@ -5195,7 +5195,7 @@
           <p:cNvPr id="7" name="text-53">
             <a:extLst xmlns:a="http://schemas.openxmlformats.org/drawingml/2006/main">
               <a:ext uri="{FF2B5EF4-FFF2-40B4-BE49-F238E27FC236}">
-                <a16:creationId xmlns:a16="http://schemas.microsoft.com/office/drawing/2014/main" id="{7BA3319A-8EB8-4E6C-9258-F78A334F91D6}"/>
+                <a16:creationId xmlns:a16="http://schemas.microsoft.com/office/drawing/2014/main" id="{625F6173-3072-4BED-B650-B53A21B3661C}"/>
               </a:ext>
             </a:extLst>
           </p:cNvPr>
@@ -5242,7 +5242,7 @@
                 <a:ea typeface="Arial"/>
                 <a:cs typeface="Arial"/>
               </a:rPr>
-              <a:t>Codex completed the product</a:t>
+              <a:t>Additional tools supported</a:t>
             </a:r>
           </a:p>
           <a:p xmlns:a="http://schemas.openxmlformats.org/drawingml/2006/main">
@@ -5265,7 +5265,7 @@
                 <a:ea typeface="Arial"/>
                 <a:cs typeface="Arial"/>
               </a:rPr>
-              <a:t>and later refinements.</a:t>
+              <a:t>completion and refinements.</a:t>
             </a:r>
           </a:p>
         </p:txBody>
@@ -5279,7 +5279,7 @@
           <p:nvPr/>
         </p:nvPicPr>
         <p:blipFill>
-          <a:blip xmlns:r="http://schemas.openxmlformats.org/officeDocument/2006/relationships" xmlns:a="http://schemas.openxmlformats.org/drawingml/2006/main" r:embed="R4a78afeab2a945f6"/>
+          <a:blip xmlns:r="http://schemas.openxmlformats.org/officeDocument/2006/relationships" xmlns:a="http://schemas.openxmlformats.org/drawingml/2006/main" r:embed="R869bbec1a4064563"/>
           <a:stretch xmlns:a="http://schemas.openxmlformats.org/drawingml/2006/main"/>
         </p:blipFill>
         <p:spPr>
@@ -5295,7 +5295,7 @@
     </p:spTree>
     <p:extLst>
       <p:ext uri="{BB962C8B-B14F-4D97-AF65-F5344CB8AC3E}">
-        <p14:creationId xmlns:p14="http://schemas.microsoft.com/office/powerpoint/2010/main" val="1507936268"/>
+        <p14:creationId xmlns:p14="http://schemas.microsoft.com/office/powerpoint/2010/main" val="1791956569"/>
       </p:ext>
     </p:extLst>
   </p:cSld>
@@ -5326,7 +5326,7 @@
           <p:cNvPr id="10" name="text-54">
             <a:extLst xmlns:a="http://schemas.openxmlformats.org/drawingml/2006/main">
               <a:ext uri="{FF2B5EF4-FFF2-40B4-BE49-F238E27FC236}">
-                <a16:creationId xmlns:a16="http://schemas.microsoft.com/office/drawing/2014/main" id="{A7771F91-4D82-49BF-9681-95890453BFA9}"/>
+                <a16:creationId xmlns:a16="http://schemas.microsoft.com/office/drawing/2014/main" id="{E35A149F-BC83-4F7D-8B7A-6A3F1F175D95}"/>
               </a:ext>
             </a:extLst>
           </p:cNvPr>
@@ -5383,7 +5383,7 @@
           <p:cNvPr id="2" name="text-55">
             <a:extLst xmlns:a="http://schemas.openxmlformats.org/drawingml/2006/main">
               <a:ext uri="{FF2B5EF4-FFF2-40B4-BE49-F238E27FC236}">
-                <a16:creationId xmlns:a16="http://schemas.microsoft.com/office/drawing/2014/main" id="{A9DEFFB4-7FD0-448D-8641-F3EA488753D5}"/>
+                <a16:creationId xmlns:a16="http://schemas.microsoft.com/office/drawing/2014/main" id="{0A42D53F-DC6C-4B7D-81BB-F3A523472894}"/>
               </a:ext>
             </a:extLst>
           </p:cNvPr>
@@ -5440,7 +5440,7 @@
           <p:cNvPr id="3" name="text-56">
             <a:extLst xmlns:a="http://schemas.openxmlformats.org/drawingml/2006/main">
               <a:ext uri="{FF2B5EF4-FFF2-40B4-BE49-F238E27FC236}">
-                <a16:creationId xmlns:a16="http://schemas.microsoft.com/office/drawing/2014/main" id="{07D4A9F0-B135-4AAA-AED1-0BBF4D30557F}"/>
+                <a16:creationId xmlns:a16="http://schemas.microsoft.com/office/drawing/2014/main" id="{D944FE63-517D-4A04-AC21-B29EFDEAEF74}"/>
               </a:ext>
             </a:extLst>
           </p:cNvPr>
@@ -5497,7 +5497,7 @@
           <p:cNvPr id="4" name="text-57">
             <a:extLst xmlns:a="http://schemas.openxmlformats.org/drawingml/2006/main">
               <a:ext uri="{FF2B5EF4-FFF2-40B4-BE49-F238E27FC236}">
-                <a16:creationId xmlns:a16="http://schemas.microsoft.com/office/drawing/2014/main" id="{101A5A45-F529-4D27-B28E-D2E155159ACC}"/>
+                <a16:creationId xmlns:a16="http://schemas.microsoft.com/office/drawing/2014/main" id="{6B690B64-A898-483E-8D8C-D2BEF8365E48}"/>
               </a:ext>
             </a:extLst>
           </p:cNvPr>
@@ -5600,7 +5600,7 @@
           <p:cNvPr id="5" name="text-58">
             <a:extLst xmlns:a="http://schemas.openxmlformats.org/drawingml/2006/main">
               <a:ext uri="{FF2B5EF4-FFF2-40B4-BE49-F238E27FC236}">
-                <a16:creationId xmlns:a16="http://schemas.microsoft.com/office/drawing/2014/main" id="{5EA519DC-A830-4089-BAF6-A75473EC5BCC}"/>
+                <a16:creationId xmlns:a16="http://schemas.microsoft.com/office/drawing/2014/main" id="{BBB9CAFB-264A-41B7-B047-B86C57CDFCE1}"/>
               </a:ext>
             </a:extLst>
           </p:cNvPr>
@@ -5657,7 +5657,7 @@
           <p:cNvPr id="6" name="text-59">
             <a:extLst xmlns:a="http://schemas.openxmlformats.org/drawingml/2006/main">
               <a:ext uri="{FF2B5EF4-FFF2-40B4-BE49-F238E27FC236}">
-                <a16:creationId xmlns:a16="http://schemas.microsoft.com/office/drawing/2014/main" id="{5DBC77AA-D27F-418E-A0E4-536199D95EC7}"/>
+                <a16:creationId xmlns:a16="http://schemas.microsoft.com/office/drawing/2014/main" id="{A51851EE-726F-434B-BA9E-70547E206956}"/>
               </a:ext>
             </a:extLst>
           </p:cNvPr>
@@ -5760,7 +5760,7 @@
           <p:cNvPr id="7" name="text-60">
             <a:extLst xmlns:a="http://schemas.openxmlformats.org/drawingml/2006/main">
               <a:ext uri="{FF2B5EF4-FFF2-40B4-BE49-F238E27FC236}">
-                <a16:creationId xmlns:a16="http://schemas.microsoft.com/office/drawing/2014/main" id="{018FA931-ACE7-45C4-9DD0-C7FA3171D59E}"/>
+                <a16:creationId xmlns:a16="http://schemas.microsoft.com/office/drawing/2014/main" id="{1C29321A-CCEB-42D6-A987-3B3ECBACF5D2}"/>
               </a:ext>
             </a:extLst>
           </p:cNvPr>
@@ -5817,7 +5817,7 @@
           <p:cNvPr id="8" name="text-61">
             <a:extLst xmlns:a="http://schemas.openxmlformats.org/drawingml/2006/main">
               <a:ext uri="{FF2B5EF4-FFF2-40B4-BE49-F238E27FC236}">
-                <a16:creationId xmlns:a16="http://schemas.microsoft.com/office/drawing/2014/main" id="{7A2F5A9D-A9F4-4690-B15E-9CA6A40EA34C}"/>
+                <a16:creationId xmlns:a16="http://schemas.microsoft.com/office/drawing/2014/main" id="{62CF0408-D4CB-4E8A-9EA6-C00320AD0301}"/>
               </a:ext>
             </a:extLst>
           </p:cNvPr>
@@ -5920,7 +5920,7 @@
           <p:cNvPr id="9" name="text-62">
             <a:extLst xmlns:a="http://schemas.openxmlformats.org/drawingml/2006/main">
               <a:ext uri="{FF2B5EF4-FFF2-40B4-BE49-F238E27FC236}">
-                <a16:creationId xmlns:a16="http://schemas.microsoft.com/office/drawing/2014/main" id="{219410E8-66A8-439A-9DCB-75BD2A6E7801}"/>
+                <a16:creationId xmlns:a16="http://schemas.microsoft.com/office/drawing/2014/main" id="{E655C62B-A10F-42FD-A1C8-5A4717D4D8F3}"/>
               </a:ext>
             </a:extLst>
           </p:cNvPr>
@@ -5975,7 +5975,7 @@
     </p:spTree>
     <p:extLst>
       <p:ext uri="{BB962C8B-B14F-4D97-AF65-F5344CB8AC3E}">
-        <p14:creationId xmlns:p14="http://schemas.microsoft.com/office/powerpoint/2010/main" val="1337267510"/>
+        <p14:creationId xmlns:p14="http://schemas.microsoft.com/office/powerpoint/2010/main" val="293354580"/>
       </p:ext>
     </p:extLst>
   </p:cSld>
@@ -6010,7 +6010,7 @@
           <p:nvPr/>
         </p:nvPicPr>
         <p:blipFill>
-          <a:blip xmlns:r="http://schemas.openxmlformats.org/officeDocument/2006/relationships" xmlns:a="http://schemas.openxmlformats.org/drawingml/2006/main" r:embed="R5d9cc3fef76a4707"/>
+          <a:blip xmlns:r="http://schemas.openxmlformats.org/officeDocument/2006/relationships" xmlns:a="http://schemas.openxmlformats.org/drawingml/2006/main" r:embed="R05e248a546064e3b"/>
           <a:srcRect xmlns:a="http://schemas.openxmlformats.org/drawingml/2006/main" l="0" t="7813" r="0" b="7813"/>
           <a:stretch xmlns:a="http://schemas.openxmlformats.org/drawingml/2006/main">
             <a:fillRect l="0" t="0" r="0" b="0"/>
@@ -6031,7 +6031,7 @@
           <p:cNvPr id="2" name="text-63">
             <a:extLst xmlns:a="http://schemas.openxmlformats.org/drawingml/2006/main">
               <a:ext uri="{FF2B5EF4-FFF2-40B4-BE49-F238E27FC236}">
-                <a16:creationId xmlns:a16="http://schemas.microsoft.com/office/drawing/2014/main" id="{0C939F74-367E-43C6-AB4B-3FC8E9FA754E}"/>
+                <a16:creationId xmlns:a16="http://schemas.microsoft.com/office/drawing/2014/main" id="{A82078E3-47E2-4F2A-BE8F-9568DB90D381}"/>
               </a:ext>
             </a:extLst>
           </p:cNvPr>
@@ -6088,7 +6088,7 @@
           <p:cNvPr id="3" name="text-64">
             <a:extLst xmlns:a="http://schemas.openxmlformats.org/drawingml/2006/main">
               <a:ext uri="{FF2B5EF4-FFF2-40B4-BE49-F238E27FC236}">
-                <a16:creationId xmlns:a16="http://schemas.microsoft.com/office/drawing/2014/main" id="{F2E27FA8-EAC1-48CE-B01F-7EBA338DCFE5}"/>
+                <a16:creationId xmlns:a16="http://schemas.microsoft.com/office/drawing/2014/main" id="{251998A1-D92E-46CD-BEDD-88A03C7F66F0}"/>
               </a:ext>
             </a:extLst>
           </p:cNvPr>
@@ -6145,7 +6145,7 @@
           <p:cNvPr id="4" name="text-65">
             <a:extLst xmlns:a="http://schemas.openxmlformats.org/drawingml/2006/main">
               <a:ext uri="{FF2B5EF4-FFF2-40B4-BE49-F238E27FC236}">
-                <a16:creationId xmlns:a16="http://schemas.microsoft.com/office/drawing/2014/main" id="{BBFF273A-3912-4E5B-936D-2FEF2A54A5CE}"/>
+                <a16:creationId xmlns:a16="http://schemas.microsoft.com/office/drawing/2014/main" id="{36F26F72-1609-444A-BF83-799FE47F1454}"/>
               </a:ext>
             </a:extLst>
           </p:cNvPr>
@@ -6202,7 +6202,7 @@
           <p:cNvPr id="5" name="text-66">
             <a:extLst xmlns:a="http://schemas.openxmlformats.org/drawingml/2006/main">
               <a:ext uri="{FF2B5EF4-FFF2-40B4-BE49-F238E27FC236}">
-                <a16:creationId xmlns:a16="http://schemas.microsoft.com/office/drawing/2014/main" id="{728C1F8E-B8ED-406C-8A20-C7135913B8BD}"/>
+                <a16:creationId xmlns:a16="http://schemas.microsoft.com/office/drawing/2014/main" id="{CAEF5A3A-E0DD-414A-AAC7-96C7E03EE241}"/>
               </a:ext>
             </a:extLst>
           </p:cNvPr>
@@ -6245,7 +6245,7 @@
                 <a:solidFill>
                   <a:srgbClr val="EDF1FB"/>
                 </a:solidFill>
-                <a:hlinkClick xmlns:r="http://schemas.openxmlformats.org/officeDocument/2006/relationships" r:id="Rf6ba9762a05f48d4"/>
+                <a:hlinkClick xmlns:r="http://schemas.openxmlformats.org/officeDocument/2006/relationships" r:id="R32ff9fb487f94980"/>
               </a:rPr>
               <a:t>ming-acceptance-proof.amosming.chatgpt.site</a:t>
             </a:r>
@@ -6257,7 +6257,7 @@
           <p:cNvPr id="6" name="text-67">
             <a:extLst xmlns:a="http://schemas.openxmlformats.org/drawingml/2006/main">
               <a:ext uri="{FF2B5EF4-FFF2-40B4-BE49-F238E27FC236}">
-                <a16:creationId xmlns:a16="http://schemas.microsoft.com/office/drawing/2014/main" id="{A89AC6E7-DEEE-4F4F-8270-055650E52F7E}"/>
+                <a16:creationId xmlns:a16="http://schemas.microsoft.com/office/drawing/2014/main" id="{D25F5119-D0DD-49EE-9802-429FA554EC1D}"/>
               </a:ext>
             </a:extLst>
           </p:cNvPr>
@@ -6300,7 +6300,7 @@
                 <a:solidFill>
                   <a:srgbClr val="EDF1FB"/>
                 </a:solidFill>
-                <a:hlinkClick xmlns:r="http://schemas.openxmlformats.org/officeDocument/2006/relationships" r:id="R38511b54b3d342a7"/>
+                <a:hlinkClick xmlns:r="http://schemas.openxmlformats.org/officeDocument/2006/relationships" r:id="R23f0aff73b6545a0"/>
               </a:rPr>
               <a:t>github.com/Ming-Amos/Ming</a:t>
             </a:r>
@@ -6312,7 +6312,7 @@
           <p:cNvPr id="7" name="text-68">
             <a:extLst xmlns:a="http://schemas.openxmlformats.org/drawingml/2006/main">
               <a:ext uri="{FF2B5EF4-FFF2-40B4-BE49-F238E27FC236}">
-                <a16:creationId xmlns:a16="http://schemas.microsoft.com/office/drawing/2014/main" id="{8FABD1EC-0AE8-49C3-9345-0B3142B12641}"/>
+                <a16:creationId xmlns:a16="http://schemas.microsoft.com/office/drawing/2014/main" id="{71B0CED3-A7AA-4097-A7D1-5E75C5DD2AD6}"/>
               </a:ext>
             </a:extLst>
           </p:cNvPr>
@@ -6367,7 +6367,7 @@
     </p:spTree>
     <p:extLst>
       <p:ext uri="{BB962C8B-B14F-4D97-AF65-F5344CB8AC3E}">
-        <p14:creationId xmlns:p14="http://schemas.microsoft.com/office/powerpoint/2010/main" val="1489931932"/>
+        <p14:creationId xmlns:p14="http://schemas.microsoft.com/office/powerpoint/2010/main" val="263355879"/>
       </p:ext>
     </p:extLst>
   </p:cSld>

</xml_diff>